<commit_message>
docs(submission): align all submission dossier, readmes, deck, and video script for CargoClear
</commit_message>
<xml_diff>
--- a/submission/CargoClear_AI_Builder_Cup_Submission.pptx
+++ b/submission/CargoClear_AI_Builder_Cup_Submission.pptx
@@ -7052,7 +7052,7 @@
               <a:defRPr sz="1600" b="1"/>
             </a:pPr>
             <a:r>
-              <a:t>Team name: [TEAM NAME — REQUIRED] (CargoClear Team)</a:t>
+              <a:t>Team name: CargoClear</a:t>
             </a:r>
             <a:endParaRPr sz="1800">
               <a:latin typeface="Google Sans Flex"/>
@@ -7075,7 +7075,7 @@
               <a:defRPr sz="1600" b="1"/>
             </a:pPr>
             <a:r>
-              <a:t>Team leader name: [TEAM LEADER — REQUIRED]</a:t>
+              <a:t>Team leader name: Ravi Mule (Team Member: Nikhil Pande)</a:t>
             </a:r>
             <a:endParaRPr sz="1800">
               <a:latin typeface="Google Sans Flex"/>
@@ -7407,7 +7407,7 @@
               </a:defRPr>
             </a:pPr>
             <a:r>
-              <a:t>• Cloud Run Frontend &amp; API Services: Runs on Google Cloud Run with scale-to-zero. Baseline free tier covers 2 million requests/month. Projected cost for production pilot: ~$15.00 – $25.00 / month.</a:t>
+              <a:t>• Cloud Run Frontend &amp; API Services: Deployed with --min-instances 0 (scale-to-zero), delivering $0.00 idle compute cost. Monthly compute for 5,000 assessments falls within Cloud Run Free Tier (2M requests/mo free). Projected compute: $0.00 – $2.00 / month.</a:t>
             </a:r>
           </a:p>
           <a:p>
@@ -7437,7 +7437,7 @@
               </a:defRPr>
             </a:pPr>
             <a:r>
-              <a:t>• Cloud Storage &amp; Firestore Ledger: Document storage (10 MB/shipment) + Firestore read/write operations for audit ledger. Projected cost: ~$5.00 – $10.00 / month.</a:t>
+              <a:t>• Cloud Storage &amp; Firestore Native Ledger: Document storage (10 MB/shipment) + Firestore native user registration and audit ledger read/writes. Projected cost: ~$5.00 – $10.00 / month.</a:t>
             </a:r>
           </a:p>
           <a:p>
@@ -7467,7 +7467,7 @@
               </a:defRPr>
             </a:pPr>
             <a:r>
-              <a:t>• Total Estimated Monthly Operating Cost: Estimated total for 5,000 full shipment bundle assessments: ~$26.40 – $44.40 / month (less than $0.01 per clearance assessment!).</a:t>
+              <a:t>• Total Estimated Monthly Operating Cost: Estimated total for 5,000 full shipment bundle assessments: ~$11.40 – $21.40 / month (less than $0.005 per clearance assessment!).</a:t>
             </a:r>
           </a:p>
         </p:txBody>
@@ -7695,7 +7695,7 @@
               </a:defRPr>
             </a:pPr>
             <a:r>
-              <a:t>• 1. Commercial SSO &amp; Tenant Dashboard: Google Workspace SSO integration, role-based licensing (Licensed CHA, Operator, Auditor), tenant scoping, and recent bundles table with status pills.</a:t>
+              <a:t>• 1. Commercial Auth &amp; Tenant Dashboard: Google Workspace SSO plus Cloud Firestore commercial registration (salted PBKDF2-HMAC-SHA256 password hashing), user profile menu with 3-way theme controls, and recent bundles table.</a:t>
             </a:r>
           </a:p>
           <a:p>
@@ -7710,7 +7710,7 @@
               </a:defRPr>
             </a:pPr>
             <a:r>
-              <a:t>• 2. Interactive 3-Pane Clearance Workbench: Multi-document bundle view with side-by-side high-resolution PDF rendering, document switcher, and live upload progress.</a:t>
+              <a:t>• 2. Tripartite Clearance Workbench: Next.js 15 workbench with 3-way layout switcher (Split, Viewer focus, Decision focus), auto-hiding PDF view during analysis with automated focus scrolling to live progress bar.</a:t>
             </a:r>
           </a:p>
           <a:p>
@@ -7725,7 +7725,7 @@
               </a:defRPr>
             </a:pPr>
             <a:r>
-              <a:t>• 3. Visual Evidence Grounding &amp; Bounding Boxes: Direct coordinate overlays on trade documents highlighting discrepancies (e.g. invoice gross weight vs. packing list weight) and chemistry mismatches.</a:t>
+              <a:t>• 3. Pre-Upload Staging &amp; Classification: Portaled document classification modal (z-[9999]) enabling customs brokers to categorize document types prior to ingestion.</a:t>
             </a:r>
           </a:p>
           <a:p>
@@ -7740,7 +7740,7 @@
               </a:defRPr>
             </a:pPr>
             <a:r>
-              <a:t>• 4. Tariff Valuation &amp; Anti-Dumping Calculation: Itemized duty calculation card detailing BCD, Social Welfare Surcharge, and Anti-Dumping Duties with legal notification citations.</a:t>
+              <a:t>• 4. Visual Evidence Grounding &amp; Bounding Boxes: Direct coordinate overlays on trade documents highlighting discrepancies (e.g. invoice gross weight vs. packing list weight) and chemistry mismatches.</a:t>
             </a:r>
           </a:p>
           <a:p>
@@ -7755,7 +7755,7 @@
               </a:defRPr>
             </a:pPr>
             <a:r>
-              <a:t>• 5. Human-in-the-Loop Corrections &amp; Audit Trail: Authorized override modal with instant zero-model recomputation and cryptographically signed SHA-256 audit log timeline.</a:t>
+              <a:t>• 5. Tariff Valuation, In-Place Override &amp; Audit Ledger: Itemized duty calculation card (BCD, SWS, ADD), authorized override modal with instant zero-model recomputation, and cryptographically signed SHA-256 audit log timeline.</a:t>
             </a:r>
           </a:p>
         </p:txBody>
@@ -8588,7 +8588,7 @@
               <a:defRPr sz="1600" b="1"/>
             </a:pPr>
             <a:r>
-              <a:t>GitHub Public Repository: [GITHUB REPOSITORY URL — REQUIRED] (https://github.com/ravimule93/cargoclear)</a:t>
+              <a:t>GitHub Public Repository: https://github.com/ravimule93/cargoclear (Branch: improvement-plan)</a:t>
             </a:r>
             <a:endParaRPr>
               <a:latin typeface="Google Sans Flex Medium"/>
@@ -8611,7 +8611,7 @@
               <a:defRPr sz="1600" b="1"/>
             </a:pPr>
             <a:r>
-              <a:t>Demo Video Link (3 Minutes): [DEMO VIDEO LINK — REQUIRED]</a:t>
+              <a:t>Demo Video Link (3 Minutes): [DEMO VIDEO LINK — Insert URL here] (Narrative script in submission dossier)</a:t>
             </a:r>
             <a:endParaRPr>
               <a:latin typeface="Google Sans Flex Medium"/>
@@ -10163,7 +10163,7 @@
           <a:p>
             <a:pPr>
               <a:spcAft>
-                <a:spcPts val="600"/>
+                <a:spcPts val="400"/>
               </a:spcAft>
               <a:defRPr sz="1600" b="1">
                 <a:solidFill>
@@ -10178,24 +10178,69 @@
           <a:p>
             <a:pPr>
               <a:spcAft>
-                <a:spcPts val="500"/>
-              </a:spcAft>
-              <a:defRPr sz="1200" b="0">
+                <a:spcPts val="300"/>
+              </a:spcAft>
+              <a:defRPr sz="1050" b="0">
                 <a:solidFill>
                   <a:srgbClr val="1E293B"/>
                 </a:solidFill>
               </a:defRPr>
             </a:pPr>
             <a:r>
+              <a:t>• Tripartite Clearance Layout Switcher: 3-way layout switcher (Split, Viewer focus, Decision focus), auto-hiding PDF view during analysis with automated focus scrolling to live progress bar.</a:t>
+            </a:r>
+          </a:p>
+          <a:p>
+            <a:pPr>
+              <a:spcAft>
+                <a:spcPts val="300"/>
+              </a:spcAft>
+              <a:defRPr sz="1050" b="0">
+                <a:solidFill>
+                  <a:srgbClr val="1E293B"/>
+                </a:solidFill>
+              </a:defRPr>
+            </a:pPr>
+            <a:r>
+              <a:t>• Pre-Upload Document Staging &amp; Classification: Portaled classification modal (z-[9999]) enabling customs brokers to categorize document types prior to ingestion.</a:t>
+            </a:r>
+          </a:p>
+          <a:p>
+            <a:pPr>
+              <a:spcAft>
+                <a:spcPts val="300"/>
+              </a:spcAft>
+              <a:defRPr sz="1050" b="0">
+                <a:solidFill>
+                  <a:srgbClr val="1E293B"/>
+                </a:solidFill>
+              </a:defRPr>
+            </a:pPr>
+            <a:r>
+              <a:t>• Commercial Registration &amp; Corporate Auth: Google Workspace SSO plus Cloud Firestore commercial registration with salted PBKDF2-HMAC-SHA256 password hashing and audit trails.</a:t>
+            </a:r>
+          </a:p>
+          <a:p>
+            <a:pPr>
+              <a:spcAft>
+                <a:spcPts val="300"/>
+              </a:spcAft>
+              <a:defRPr sz="1050" b="0">
+                <a:solidFill>
+                  <a:srgbClr val="1E293B"/>
+                </a:solidFill>
+              </a:defRPr>
+            </a:pPr>
+            <a:r>
               <a:t>• Multimodal Ingestion &amp; PDF Normalization: Processes multi-page trade bundles with page-level coordinate mapping and thumbnail generation.</a:t>
             </a:r>
           </a:p>
           <a:p>
             <a:pPr>
               <a:spcAft>
-                <a:spcPts val="500"/>
-              </a:spcAft>
-              <a:defRPr sz="1200" b="0">
+                <a:spcPts val="300"/>
+              </a:spcAft>
+              <a:defRPr sz="1050" b="0">
                 <a:solidFill>
                   <a:srgbClr val="1E293B"/>
                 </a:solidFill>
@@ -10208,9 +10253,9 @@
           <a:p>
             <a:pPr>
               <a:spcAft>
-                <a:spcPts val="500"/>
-              </a:spcAft>
-              <a:defRPr sz="1200" b="0">
+                <a:spcPts val="300"/>
+              </a:spcAft>
+              <a:defRPr sz="1050" b="0">
                 <a:solidFill>
                   <a:srgbClr val="1E293B"/>
                 </a:solidFill>
@@ -10223,9 +10268,9 @@
           <a:p>
             <a:pPr>
               <a:spcAft>
-                <a:spcPts val="500"/>
-              </a:spcAft>
-              <a:defRPr sz="1200" b="0">
+                <a:spcPts val="300"/>
+              </a:spcAft>
+              <a:defRPr sz="1050" b="0">
                 <a:solidFill>
                   <a:srgbClr val="1E293B"/>
                 </a:solidFill>
@@ -10238,9 +10283,9 @@
           <a:p>
             <a:pPr>
               <a:spcAft>
-                <a:spcPts val="500"/>
-              </a:spcAft>
-              <a:defRPr sz="1200" b="0">
+                <a:spcPts val="300"/>
+              </a:spcAft>
+              <a:defRPr sz="1050" b="0">
                 <a:solidFill>
                   <a:srgbClr val="1E293B"/>
                 </a:solidFill>
@@ -10253,9 +10298,9 @@
           <a:p>
             <a:pPr>
               <a:spcAft>
-                <a:spcPts val="500"/>
-              </a:spcAft>
-              <a:defRPr sz="1200" b="0">
+                <a:spcPts val="300"/>
+              </a:spcAft>
+              <a:defRPr sz="1050" b="0">
                 <a:solidFill>
                   <a:srgbClr val="1E293B"/>
                 </a:solidFill>
@@ -10268,9 +10313,9 @@
           <a:p>
             <a:pPr>
               <a:spcAft>
-                <a:spcPts val="500"/>
-              </a:spcAft>
-              <a:defRPr sz="1200" b="0">
+                <a:spcPts val="300"/>
+              </a:spcAft>
+              <a:defRPr sz="1050" b="0">
                 <a:solidFill>
                   <a:srgbClr val="1E293B"/>
                 </a:solidFill>
@@ -10283,9 +10328,9 @@
           <a:p>
             <a:pPr>
               <a:spcAft>
-                <a:spcPts val="500"/>
-              </a:spcAft>
-              <a:defRPr sz="1200" b="0">
+                <a:spcPts val="300"/>
+              </a:spcAft>
+              <a:defRPr sz="1050" b="0">
                 <a:solidFill>
                   <a:srgbClr val="1E293B"/>
                 </a:solidFill>

</xml_diff>